<commit_message>
Deixa só as três analogias principais na apresentação oficial
Ficam o patch de Street Fighter (slide 2, intensidade de exposição), o scouter
do Dragon Ball (slide 9, associação não é causa) e o save corrompido (slide 11,
quebra da medida em 2020 e 2021). Saem as dos slides 3, 4, 5, 6, 7, 8 e 10.
Com as três, a fala soma cerca de 13:03 a 125 palavras por minuto. Só as notas
mudaram.

Co-Authored-By: Claude Opus 5.5 <noreply@anthropic.com>
</commit_message>
<xml_diff>
--- a/apresentacao/apresentacao_dissertacao_oficial.pptx
+++ b/apresentacao/apresentacao_dissertacao_oficial.pptx
@@ -2922,26 +2922,6 @@
               <a:t>Por fim, o controle: a chance de reencontrar a pessoa quase variou com a exposição, perto do limite de significância. Não posso descartar que as perdas de entrevista influenciem o resultado.</a:t>
             </a:r>
           </a:p>
-          <a:p/>
-          <a:p/>
-          <a:p>
-            <a:r>
-              <a:rPr b="1">
-                <a:solidFill>
-                  <a:srgbClr val="C55A11"/>
-                </a:solidFill>
-              </a:rPr>
-              <a:t>ANALOGIA OPCIONAL: </a:t>
-            </a:r>
-            <a:r>
-              <a:rPr i="1">
-                <a:solidFill>
-                  <a:srgbClr val="C55A11"/>
-                </a:solidFill>
-              </a:rPr>
-              <a:t>É como esperar que a barra de vida do personagem mais exposto caísse, e ela simplesmente não caiu. É a reviravolta do capítulo.</a:t>
-            </a:r>
-          </a:p>
         </p:txBody>
       </p:sp>
       <p:sp>
@@ -3790,26 +3770,6 @@
               <a:t>E aqui está a lacuna: no Brasil, nenhuma pesquisa grande pergunta quem usa IA no trabalho. Por isso uso o que existe: a exposição da ocupação, numa pesquisa feita nos domicílios.</a:t>
             </a:r>
           </a:p>
-          <a:p/>
-          <a:p/>
-          <a:p>
-            <a:r>
-              <a:rPr b="1">
-                <a:solidFill>
-                  <a:srgbClr val="C55A11"/>
-                </a:solidFill>
-              </a:rPr>
-              <a:t>ANALOGIA OPCIONAL: </a:t>
-            </a:r>
-            <a:r>
-              <a:rPr i="1">
-                <a:solidFill>
-                  <a:srgbClr val="C55A11"/>
-                </a:solidFill>
-              </a:rPr>
-              <a:t>É como ter ótimos relatórios de scout de vários campeonatos, mas nenhum do Brasileirão. Então eu uso os dados que o próprio campeonato brasileiro já tem.</a:t>
-            </a:r>
-          </a:p>
         </p:txBody>
       </p:sp>
       <p:sp>
@@ -4014,26 +3974,6 @@
               <a:t>Um detalhe: eu conto transições, não pessoas. A mesma pessoa pode aparecer até quatro vezes.</a:t>
             </a:r>
           </a:p>
-          <a:p/>
-          <a:p/>
-          <a:p>
-            <a:r>
-              <a:rPr b="1">
-                <a:solidFill>
-                  <a:srgbClr val="C55A11"/>
-                </a:solidFill>
-              </a:rPr>
-              <a:t>ANALOGIA OPCIONAL: </a:t>
-            </a:r>
-            <a:r>
-              <a:rPr i="1">
-                <a:solidFill>
-                  <a:srgbClr val="C55A11"/>
-                </a:solidFill>
-              </a:rPr>
-              <a:t>É como reconhecer um lutador sem o nome na tela, só pelas características: altura, golpe especial, estilo de luta. Eu faço o mesmo com as pistas de domicílio, sexo e data de nascimento.</a:t>
-            </a:r>
-          </a:p>
         </p:txBody>
       </p:sp>
       <p:sp>
@@ -4235,26 +4175,6 @@
               <a:t>E há outro obstáculo: as ocupações mais expostas à IA também são as que mais podem ser feitas de casa. A correlação é de 0,7. Por isso o teletrabalho entra no modelo, para a IA não levar o crédito pelo que foi efeito da pandemia.</a:t>
             </a:r>
           </a:p>
-          <a:p/>
-          <a:p/>
-          <a:p>
-            <a:r>
-              <a:rPr b="1">
-                <a:solidFill>
-                  <a:srgbClr val="C55A11"/>
-                </a:solidFill>
-              </a:rPr>
-              <a:t>ANALOGIA OPCIONAL: </a:t>
-            </a:r>
-            <a:r>
-              <a:rPr i="1">
-                <a:solidFill>
-                  <a:srgbClr val="C55A11"/>
-                </a:solidFill>
-              </a:rPr>
-              <a:t>É como traduzir os nomes dos personagens de um jogo americano para a versão brasileira: a tradução é boa, mas nunca é cem por cento perfeita.</a:t>
-            </a:r>
-          </a:p>
         </p:txBody>
       </p:sp>
       <p:sp>
@@ -4457,26 +4377,6 @@
               <a:t>Duas regras. Quando não sei para onde a pessoa foi, não conto esse caso: nunca assumo que ela ficou parada. E as duas direções se leem juntas, porque quem já está no topo da exposição tem mais espaço para descer do que para subir.</a:t>
             </a:r>
           </a:p>
-          <a:p/>
-          <a:p/>
-          <a:p>
-            <a:r>
-              <a:rPr b="1">
-                <a:solidFill>
-                  <a:srgbClr val="C55A11"/>
-                </a:solidFill>
-              </a:rPr>
-              <a:t>ANALOGIA OPCIONAL: </a:t>
-            </a:r>
-            <a:r>
-              <a:rPr i="1">
-                <a:solidFill>
-                  <a:srgbClr val="C55A11"/>
-                </a:solidFill>
-              </a:rPr>
-              <a:t>Pense num time: o vínculo é se o jogador saiu do time ou foi para o banco; a mobilidade é se trocou de posição; a direção é se foi para uma posição mais ou menos exposta.</a:t>
-            </a:r>
-          </a:p>
         </p:txBody>
       </p:sp>
       <p:sp>
@@ -4673,26 +4573,6 @@
               <a:t>O modelo também leva em conta teletrabalho, idade, ocupação de origem, estado e trimestre, sexo, escolaridade e setor. E os erros são calculados por área de coleta, em mais de 30 mil grupos.</a:t>
             </a:r>
           </a:p>
-          <a:p/>
-          <a:p/>
-          <a:p>
-            <a:r>
-              <a:rPr b="1">
-                <a:solidFill>
-                  <a:srgbClr val="C55A11"/>
-                </a:solidFill>
-              </a:rPr>
-              <a:t>ANALOGIA OPCIONAL: </a:t>
-            </a:r>
-            <a:r>
-              <a:rPr i="1">
-                <a:solidFill>
-                  <a:srgbClr val="C55A11"/>
-                </a:solidFill>
-              </a:rPr>
-              <a:t>Lembra do patch de Street Fighter? O beta mede quanto a mais o personagem mais exposto sentiu a mesma atualização.</a:t>
-            </a:r>
-          </a:p>
         </p:txBody>
       </p:sp>
       <p:sp>
@@ -4903,26 +4783,6 @@
           <a:p>
             <a:r>
               <a:t>Ou seja: a mobilidade subiu para todo mundo, não só para quem está mais exposto. Essa é a tensão do trabalho: se tudo se mexeu, a IA explica alguma parte desse movimento? É isso que o modelo vai responder.</a:t>
-            </a:r>
-          </a:p>
-          <a:p/>
-          <a:p/>
-          <a:p>
-            <a:r>
-              <a:rPr b="1">
-                <a:solidFill>
-                  <a:srgbClr val="C55A11"/>
-                </a:solidFill>
-              </a:rPr>
-              <a:t>ANALOGIA OPCIONAL: </a:t>
-            </a:r>
-            <a:r>
-              <a:rPr i="1">
-                <a:solidFill>
-                  <a:srgbClr val="C55A11"/>
-                </a:solidFill>
-              </a:rPr>
-              <a:t>É como notar que o time inteiro do Palmeiras correu mais no returno, do zagueiro ao atacante. Antes de elogiar um jogador, o técnico precisa checar se mudou a preparação física de todos.</a:t>
             </a:r>
           </a:p>
         </p:txBody>

</xml_diff>